<commit_message>
Refresh course materials and quartile explanation
Updated `lecturemenu3.Rmd` (and rendered HTML/PDF) to clarify quartile definitions in software, shifting from R-specific wording to a broader explanation of interpolation vs. median-of-halves/Tukey hinges and reinforcing the class convention. Also refreshed published course artifacts, including Week 3 slide decks (PDF/PPTX), lecture menu PDFs, and several site PDFs/schedule documents; related HTML files were re-rendered, producing widget ID updates.
</commit_message>
<xml_diff>
--- a/docs/lecture_slides/Week 3/Week3_Lecture6_Slides_9_9_2026.pptx
+++ b/docs/lecture_slides/Week 3/Week3_Lecture6_Slides_9_9_2026.pptx
@@ -3535,8 +3535,8 @@
           </a:p>
         </p:txBody>
       </p:sp>
-      <mc:AlternateContent xmlns:mc="http://schemas.openxmlformats.org/markup-compatibility/2006">
-        <mc:Choice xmlns:a14="http://schemas.microsoft.com/office/drawing/2010/main" Requires="a14">
+      <mc:AlternateContent xmlns:mc="http://schemas.openxmlformats.org/markup-compatibility/2006" xmlns:a14="http://schemas.microsoft.com/office/drawing/2010/main">
+        <mc:Choice Requires="a14">
           <p:sp>
             <p:nvSpPr>
               <p:cNvPr id="3" name="Content Placeholder 2">
@@ -3749,7 +3749,7 @@
             </p:txBody>
           </p:sp>
         </mc:Choice>
-        <mc:Fallback>
+        <mc:Fallback xmlns="">
           <p:sp>
             <p:nvSpPr>
               <p:cNvPr id="3" name="Content Placeholder 2">
@@ -3925,7 +3925,7 @@
           <p:cNvPr id="4" name="Picture 3">
             <a:extLst>
               <a:ext uri="{FF2B5EF4-FFF2-40B4-BE49-F238E27FC236}">
-                <a16:creationId xmlns:a16="http://schemas.microsoft.com/office/drawing/2014/main" id="{B1F0E5AF-A63D-4C6C-71DD-87EE0BBB2D41}"/>
+                <a16:creationId xmlns:a16="http://schemas.microsoft.com/office/drawing/2014/main" id="{801AED81-81B4-7F61-592C-8E1A2E45FA94}"/>
               </a:ext>
             </a:extLst>
           </p:cNvPr>
@@ -3961,7 +3961,7 @@
           <p:cNvPr id="5" name="TextBox 4">
             <a:extLst>
               <a:ext uri="{FF2B5EF4-FFF2-40B4-BE49-F238E27FC236}">
-                <a16:creationId xmlns:a16="http://schemas.microsoft.com/office/drawing/2014/main" id="{3CD6F0A8-1B11-0FDC-E0F4-786F1F3691C9}"/>
+                <a16:creationId xmlns:a16="http://schemas.microsoft.com/office/drawing/2014/main" id="{DA6C5A7F-48C5-B8D4-C6BF-F580EDC5199A}"/>
               </a:ext>
             </a:extLst>
           </p:cNvPr>
@@ -3997,7 +3997,7 @@
           <p:cNvPr id="2" name="Slide Number Placeholder 1">
             <a:extLst>
               <a:ext uri="{FF2B5EF4-FFF2-40B4-BE49-F238E27FC236}">
-                <a16:creationId xmlns:a16="http://schemas.microsoft.com/office/drawing/2014/main" id="{3F29A211-A696-678A-CFDC-6DF920D24C08}"/>
+                <a16:creationId xmlns:a16="http://schemas.microsoft.com/office/drawing/2014/main" id="{7BFA7418-DBCB-2D4B-5B18-CC67633DA75C}"/>
               </a:ext>
             </a:extLst>
           </p:cNvPr>
@@ -4056,7 +4056,7 @@
           <p:cNvPr id="6" name="Body card">
             <a:extLst>
               <a:ext uri="{FF2B5EF4-FFF2-40B4-BE49-F238E27FC236}">
-                <a16:creationId xmlns:a16="http://schemas.microsoft.com/office/drawing/2014/main" id="{419A6518-1FEE-0A17-1E11-A906423A2A64}"/>
+                <a16:creationId xmlns:a16="http://schemas.microsoft.com/office/drawing/2014/main" id="{C29A3C11-1223-E90D-387B-B18E9B1ED0AC}"/>
               </a:ext>
             </a:extLst>
           </p:cNvPr>
@@ -4112,7 +4112,7 @@
           <p:cNvPr id="2" name="Title 1">
             <a:extLst>
               <a:ext uri="{FF2B5EF4-FFF2-40B4-BE49-F238E27FC236}">
-                <a16:creationId xmlns:a16="http://schemas.microsoft.com/office/drawing/2014/main" id="{07A14B4A-2BBF-9FC5-152E-DC3A3B8A23BB}"/>
+                <a16:creationId xmlns:a16="http://schemas.microsoft.com/office/drawing/2014/main" id="{DA04138C-4405-2DE3-A3B9-BE079E7710AB}"/>
               </a:ext>
             </a:extLst>
           </p:cNvPr>
@@ -4146,7 +4146,7 @@
           <p:cNvPr id="3" name="Content Placeholder 2">
             <a:extLst>
               <a:ext uri="{FF2B5EF4-FFF2-40B4-BE49-F238E27FC236}">
-                <a16:creationId xmlns:a16="http://schemas.microsoft.com/office/drawing/2014/main" id="{61FA3BF6-2B1B-7FF0-27DF-1E9842C84526}"/>
+                <a16:creationId xmlns:a16="http://schemas.microsoft.com/office/drawing/2014/main" id="{C4B8B33F-88E0-06E1-3A16-4F4A807DB20B}"/>
               </a:ext>
             </a:extLst>
           </p:cNvPr>
@@ -4226,7 +4226,7 @@
           <p:cNvPr id="4" name="Slide Number Placeholder 3">
             <a:extLst>
               <a:ext uri="{FF2B5EF4-FFF2-40B4-BE49-F238E27FC236}">
-                <a16:creationId xmlns:a16="http://schemas.microsoft.com/office/drawing/2014/main" id="{5CD58F88-B8A7-C4DB-22E2-9065F47D7209}"/>
+                <a16:creationId xmlns:a16="http://schemas.microsoft.com/office/drawing/2014/main" id="{563742FB-6AC7-AFF5-20FE-66C562C3676F}"/>
               </a:ext>
             </a:extLst>
           </p:cNvPr>
@@ -4255,7 +4255,7 @@
           <p:cNvPr id="5" name="Title rule">
             <a:extLst>
               <a:ext uri="{FF2B5EF4-FFF2-40B4-BE49-F238E27FC236}">
-                <a16:creationId xmlns:a16="http://schemas.microsoft.com/office/drawing/2014/main" id="{696C627D-3794-58D2-24FC-A3F61B288E3C}"/>
+                <a16:creationId xmlns:a16="http://schemas.microsoft.com/office/drawing/2014/main" id="{932B9A14-4646-0DCA-A374-46974873E5B5}"/>
               </a:ext>
             </a:extLst>
           </p:cNvPr>
@@ -4321,7 +4321,7 @@
     </p:spTree>
     <p:extLst>
       <p:ext uri="{BB962C8B-B14F-4D97-AF65-F5344CB8AC3E}">
-        <p14:creationId xmlns:p14="http://schemas.microsoft.com/office/powerpoint/2010/main" val="91166526"/>
+        <p14:creationId xmlns:p14="http://schemas.microsoft.com/office/powerpoint/2010/main" val="1215256809"/>
       </p:ext>
     </p:extLst>
   </p:cSld>
@@ -4438,8 +4438,8 @@
           </a:p>
         </p:txBody>
       </p:sp>
-      <mc:AlternateContent xmlns:mc="http://schemas.openxmlformats.org/markup-compatibility/2006">
-        <mc:Choice xmlns:a14="http://schemas.microsoft.com/office/drawing/2010/main" Requires="a14">
+      <mc:AlternateContent xmlns:mc="http://schemas.openxmlformats.org/markup-compatibility/2006" xmlns:a14="http://schemas.microsoft.com/office/drawing/2010/main">
+        <mc:Choice Requires="a14">
           <p:sp>
             <p:nvSpPr>
               <p:cNvPr id="3" name="Content Placeholder 2">
@@ -5103,7 +5103,7 @@
             </p:txBody>
           </p:sp>
         </mc:Choice>
-        <mc:Fallback>
+        <mc:Fallback xmlns="">
           <p:sp>
             <p:nvSpPr>
               <p:cNvPr id="3" name="Content Placeholder 2">
@@ -5369,8 +5369,8 @@
           </a:p>
         </p:txBody>
       </p:sp>
-      <mc:AlternateContent xmlns:mc="http://schemas.openxmlformats.org/markup-compatibility/2006">
-        <mc:Choice xmlns:a14="http://schemas.microsoft.com/office/drawing/2010/main" Requires="a14">
+      <mc:AlternateContent xmlns:mc="http://schemas.openxmlformats.org/markup-compatibility/2006" xmlns:a14="http://schemas.microsoft.com/office/drawing/2010/main">
+        <mc:Choice Requires="a14">
           <p:sp>
             <p:nvSpPr>
               <p:cNvPr id="3" name="Content Placeholder 2">
@@ -5741,7 +5741,7 @@
             </p:txBody>
           </p:sp>
         </mc:Choice>
-        <mc:Fallback>
+        <mc:Fallback xmlns="">
           <p:sp>
             <p:nvSpPr>
               <p:cNvPr id="3" name="Content Placeholder 2">
@@ -5900,8 +5900,8 @@
           </a:p>
         </p:txBody>
       </p:sp>
-      <mc:AlternateContent xmlns:mc="http://schemas.openxmlformats.org/markup-compatibility/2006">
-        <mc:Choice xmlns:a14="http://schemas.microsoft.com/office/drawing/2010/main" Requires="a14">
+      <mc:AlternateContent xmlns:mc="http://schemas.openxmlformats.org/markup-compatibility/2006" xmlns:a14="http://schemas.microsoft.com/office/drawing/2010/main">
+        <mc:Choice Requires="a14">
           <p:sp>
             <p:nvSpPr>
               <p:cNvPr id="2" name="Title 1">
@@ -5967,7 +5967,7 @@
             </p:txBody>
           </p:sp>
         </mc:Choice>
-        <mc:Fallback>
+        <mc:Fallback xmlns="">
           <p:sp>
             <p:nvSpPr>
               <p:cNvPr id="2" name="Title 1">
@@ -6007,8 +6007,8 @@
           </p:sp>
         </mc:Fallback>
       </mc:AlternateContent>
-      <mc:AlternateContent xmlns:mc="http://schemas.openxmlformats.org/markup-compatibility/2006">
-        <mc:Choice xmlns:a14="http://schemas.microsoft.com/office/drawing/2010/main" Requires="a14">
+      <mc:AlternateContent xmlns:mc="http://schemas.openxmlformats.org/markup-compatibility/2006" xmlns:a14="http://schemas.microsoft.com/office/drawing/2010/main">
+        <mc:Choice Requires="a14">
           <p:sp>
             <p:nvSpPr>
               <p:cNvPr id="3" name="Content Placeholder 2">
@@ -6215,7 +6215,7 @@
             </p:txBody>
           </p:sp>
         </mc:Choice>
-        <mc:Fallback>
+        <mc:Fallback xmlns="">
           <p:sp>
             <p:nvSpPr>
               <p:cNvPr id="3" name="Content Placeholder 2">
@@ -6832,7 +6832,7 @@
           <p:cNvPr id="6" name="Rectangle: Rounded Corners 5">
             <a:extLst>
               <a:ext uri="{FF2B5EF4-FFF2-40B4-BE49-F238E27FC236}">
-                <a16:creationId xmlns:a16="http://schemas.microsoft.com/office/drawing/2014/main" id="{3027D325-5E77-224B-1498-C748F255DF61}"/>
+                <a16:creationId xmlns:a16="http://schemas.microsoft.com/office/drawing/2014/main" id="{2742C01C-3EE8-E2F7-2E4A-F86684B8432E}"/>
               </a:ext>
             </a:extLst>
           </p:cNvPr>
@@ -7145,7 +7145,7 @@
           <p:cNvPr id="2" name="Title 1">
             <a:extLst>
               <a:ext uri="{FF2B5EF4-FFF2-40B4-BE49-F238E27FC236}">
-                <a16:creationId xmlns:a16="http://schemas.microsoft.com/office/drawing/2014/main" id="{7EC4D03D-CCC2-AA42-0675-445838C2959F}"/>
+                <a16:creationId xmlns:a16="http://schemas.microsoft.com/office/drawing/2014/main" id="{803F6A12-195C-CFCB-6698-37F2F4787CBE}"/>
               </a:ext>
             </a:extLst>
           </p:cNvPr>
@@ -7179,7 +7179,7 @@
           <p:cNvPr id="3" name="Content Placeholder 2">
             <a:extLst>
               <a:ext uri="{FF2B5EF4-FFF2-40B4-BE49-F238E27FC236}">
-                <a16:creationId xmlns:a16="http://schemas.microsoft.com/office/drawing/2014/main" id="{73C464AF-AFF9-DDEF-311A-D05705D1D332}"/>
+                <a16:creationId xmlns:a16="http://schemas.microsoft.com/office/drawing/2014/main" id="{7D4C8F69-8C2F-69A1-770D-BE95AA8D8395}"/>
               </a:ext>
             </a:extLst>
           </p:cNvPr>
@@ -7228,7 +7228,7 @@
           <p:cNvPr id="4" name="Slide Number Placeholder 3">
             <a:extLst>
               <a:ext uri="{FF2B5EF4-FFF2-40B4-BE49-F238E27FC236}">
-                <a16:creationId xmlns:a16="http://schemas.microsoft.com/office/drawing/2014/main" id="{71DC2ECB-9BF2-BB53-B9F4-840EFA80058D}"/>
+                <a16:creationId xmlns:a16="http://schemas.microsoft.com/office/drawing/2014/main" id="{56742FC3-9CF4-B66A-1624-24F65C97D7B8}"/>
               </a:ext>
             </a:extLst>
           </p:cNvPr>
@@ -7257,7 +7257,7 @@
           <p:cNvPr id="6" name="Picture 5">
             <a:extLst>
               <a:ext uri="{FF2B5EF4-FFF2-40B4-BE49-F238E27FC236}">
-                <a16:creationId xmlns:a16="http://schemas.microsoft.com/office/drawing/2014/main" id="{EFB9C58A-2727-2E09-DBC2-04F65A956576}"/>
+                <a16:creationId xmlns:a16="http://schemas.microsoft.com/office/drawing/2014/main" id="{903C7C14-7CBF-D386-3873-6338686F8C60}"/>
               </a:ext>
             </a:extLst>
           </p:cNvPr>
@@ -7293,7 +7293,7 @@
           <p:cNvPr id="7" name="Rectangle: Rounded Corners 6">
             <a:extLst>
               <a:ext uri="{FF2B5EF4-FFF2-40B4-BE49-F238E27FC236}">
-                <a16:creationId xmlns:a16="http://schemas.microsoft.com/office/drawing/2014/main" id="{BBB25523-50B3-8993-4BF5-2A19C849DBEF}"/>
+                <a16:creationId xmlns:a16="http://schemas.microsoft.com/office/drawing/2014/main" id="{C946B354-F320-7F79-8A0E-B513C1262676}"/>
               </a:ext>
             </a:extLst>
           </p:cNvPr>
@@ -7454,7 +7454,7 @@
           <p:cNvPr id="8" name="Exam note">
             <a:extLst>
               <a:ext uri="{FF2B5EF4-FFF2-40B4-BE49-F238E27FC236}">
-                <a16:creationId xmlns:a16="http://schemas.microsoft.com/office/drawing/2014/main" id="{0E24953C-C874-A0AB-F162-FF6E8F057662}"/>
+                <a16:creationId xmlns:a16="http://schemas.microsoft.com/office/drawing/2014/main" id="{731C31C2-6075-E1AD-6256-06E22DD9C3E4}"/>
               </a:ext>
             </a:extLst>
           </p:cNvPr>
@@ -7490,7 +7490,7 @@
           <p:cNvPr id="5" name="Title rule">
             <a:extLst>
               <a:ext uri="{FF2B5EF4-FFF2-40B4-BE49-F238E27FC236}">
-                <a16:creationId xmlns:a16="http://schemas.microsoft.com/office/drawing/2014/main" id="{76E9FC8E-7817-9D5C-CF2A-77826A4D168B}"/>
+                <a16:creationId xmlns:a16="http://schemas.microsoft.com/office/drawing/2014/main" id="{09AC5377-F944-1933-DBA4-5C6D2FF78898}"/>
               </a:ext>
             </a:extLst>
           </p:cNvPr>
@@ -7556,7 +7556,7 @@
     </p:spTree>
     <p:extLst>
       <p:ext uri="{BB962C8B-B14F-4D97-AF65-F5344CB8AC3E}">
-        <p14:creationId xmlns:p14="http://schemas.microsoft.com/office/powerpoint/2010/main" val="1933322372"/>
+        <p14:creationId xmlns:p14="http://schemas.microsoft.com/office/powerpoint/2010/main" val="99785062"/>
       </p:ext>
     </p:extLst>
   </p:cSld>
@@ -7588,7 +7588,7 @@
           <p:cNvPr id="6" name="Body card">
             <a:extLst>
               <a:ext uri="{FF2B5EF4-FFF2-40B4-BE49-F238E27FC236}">
-                <a16:creationId xmlns:a16="http://schemas.microsoft.com/office/drawing/2014/main" id="{CAFFDAE6-07EF-F240-FB47-63CBA648EFF9}"/>
+                <a16:creationId xmlns:a16="http://schemas.microsoft.com/office/drawing/2014/main" id="{5DF7E186-66CD-65B2-9B0F-DBF4A632FC4B}"/>
               </a:ext>
             </a:extLst>
           </p:cNvPr>
@@ -7644,7 +7644,7 @@
           <p:cNvPr id="2" name="Title 1">
             <a:extLst>
               <a:ext uri="{FF2B5EF4-FFF2-40B4-BE49-F238E27FC236}">
-                <a16:creationId xmlns:a16="http://schemas.microsoft.com/office/drawing/2014/main" id="{4D6DC54E-36EA-C284-F513-8BF2B560AB46}"/>
+                <a16:creationId xmlns:a16="http://schemas.microsoft.com/office/drawing/2014/main" id="{475CE1D4-15A9-7FF0-C525-007E07F7E55D}"/>
               </a:ext>
             </a:extLst>
           </p:cNvPr>
@@ -7678,7 +7678,7 @@
           <p:cNvPr id="3" name="Content Placeholder 2">
             <a:extLst>
               <a:ext uri="{FF2B5EF4-FFF2-40B4-BE49-F238E27FC236}">
-                <a16:creationId xmlns:a16="http://schemas.microsoft.com/office/drawing/2014/main" id="{F819F6BD-D8B5-49CB-4FA6-9AD13CAEF2B3}"/>
+                <a16:creationId xmlns:a16="http://schemas.microsoft.com/office/drawing/2014/main" id="{A73E7B6F-476F-400E-F917-FC8F05B863A1}"/>
               </a:ext>
             </a:extLst>
           </p:cNvPr>
@@ -7763,7 +7763,7 @@
           <p:cNvPr id="4" name="Slide Number Placeholder 3">
             <a:extLst>
               <a:ext uri="{FF2B5EF4-FFF2-40B4-BE49-F238E27FC236}">
-                <a16:creationId xmlns:a16="http://schemas.microsoft.com/office/drawing/2014/main" id="{88C26255-CADA-670E-CB10-F0F76843790A}"/>
+                <a16:creationId xmlns:a16="http://schemas.microsoft.com/office/drawing/2014/main" id="{41A6F82F-2148-B23B-08D8-E47DACC1AD3E}"/>
               </a:ext>
             </a:extLst>
           </p:cNvPr>
@@ -7792,7 +7792,7 @@
           <p:cNvPr id="5" name="Title rule">
             <a:extLst>
               <a:ext uri="{FF2B5EF4-FFF2-40B4-BE49-F238E27FC236}">
-                <a16:creationId xmlns:a16="http://schemas.microsoft.com/office/drawing/2014/main" id="{A987A3E2-53AF-3426-E80B-DD44A05DFE14}"/>
+                <a16:creationId xmlns:a16="http://schemas.microsoft.com/office/drawing/2014/main" id="{253387AF-CD47-AA18-083E-3CFAC569B351}"/>
               </a:ext>
             </a:extLst>
           </p:cNvPr>
@@ -7858,7 +7858,7 @@
     </p:spTree>
     <p:extLst>
       <p:ext uri="{BB962C8B-B14F-4D97-AF65-F5344CB8AC3E}">
-        <p14:creationId xmlns:p14="http://schemas.microsoft.com/office/powerpoint/2010/main" val="574183280"/>
+        <p14:creationId xmlns:p14="http://schemas.microsoft.com/office/powerpoint/2010/main" val="1088731038"/>
       </p:ext>
     </p:extLst>
   </p:cSld>
@@ -7890,7 +7890,7 @@
           <p:cNvPr id="6" name="Body card">
             <a:extLst>
               <a:ext uri="{FF2B5EF4-FFF2-40B4-BE49-F238E27FC236}">
-                <a16:creationId xmlns:a16="http://schemas.microsoft.com/office/drawing/2014/main" id="{69C8D2A2-6474-8E8B-D559-AE57D07AF8F4}"/>
+                <a16:creationId xmlns:a16="http://schemas.microsoft.com/office/drawing/2014/main" id="{9E467043-7C9F-F745-3FB7-23F5DFE39944}"/>
               </a:ext>
             </a:extLst>
           </p:cNvPr>
@@ -7946,7 +7946,7 @@
           <p:cNvPr id="2" name="Title 1">
             <a:extLst>
               <a:ext uri="{FF2B5EF4-FFF2-40B4-BE49-F238E27FC236}">
-                <a16:creationId xmlns:a16="http://schemas.microsoft.com/office/drawing/2014/main" id="{AF5780AF-41C1-BBFD-4168-8D7BD829FA80}"/>
+                <a16:creationId xmlns:a16="http://schemas.microsoft.com/office/drawing/2014/main" id="{5BEE0B52-61E1-D3E2-7303-FFD87741AD70}"/>
               </a:ext>
             </a:extLst>
           </p:cNvPr>
@@ -7980,7 +7980,7 @@
           <p:cNvPr id="3" name="Content Placeholder 2">
             <a:extLst>
               <a:ext uri="{FF2B5EF4-FFF2-40B4-BE49-F238E27FC236}">
-                <a16:creationId xmlns:a16="http://schemas.microsoft.com/office/drawing/2014/main" id="{32B56EEB-ADF6-D15F-65F2-7EFC485A43DB}"/>
+                <a16:creationId xmlns:a16="http://schemas.microsoft.com/office/drawing/2014/main" id="{1A8F1990-7093-ECF3-4CB3-2C9D96E01306}"/>
               </a:ext>
             </a:extLst>
           </p:cNvPr>
@@ -8065,7 +8065,7 @@
           <p:cNvPr id="4" name="Slide Number Placeholder 3">
             <a:extLst>
               <a:ext uri="{FF2B5EF4-FFF2-40B4-BE49-F238E27FC236}">
-                <a16:creationId xmlns:a16="http://schemas.microsoft.com/office/drawing/2014/main" id="{AA60A63C-253E-1304-CE79-9BD8BA8CE849}"/>
+                <a16:creationId xmlns:a16="http://schemas.microsoft.com/office/drawing/2014/main" id="{075FD6E8-18B1-B687-D59C-D4230C916A36}"/>
               </a:ext>
             </a:extLst>
           </p:cNvPr>
@@ -8094,7 +8094,7 @@
           <p:cNvPr id="5" name="Title rule">
             <a:extLst>
               <a:ext uri="{FF2B5EF4-FFF2-40B4-BE49-F238E27FC236}">
-                <a16:creationId xmlns:a16="http://schemas.microsoft.com/office/drawing/2014/main" id="{466AD18A-5DE9-2CD2-37DA-3561776F1EC3}"/>
+                <a16:creationId xmlns:a16="http://schemas.microsoft.com/office/drawing/2014/main" id="{A785DC30-FC0E-D3EA-D9DD-4E85CC149E3C}"/>
               </a:ext>
             </a:extLst>
           </p:cNvPr>
@@ -8160,7 +8160,7 @@
     </p:spTree>
     <p:extLst>
       <p:ext uri="{BB962C8B-B14F-4D97-AF65-F5344CB8AC3E}">
-        <p14:creationId xmlns:p14="http://schemas.microsoft.com/office/powerpoint/2010/main" val="891437011"/>
+        <p14:creationId xmlns:p14="http://schemas.microsoft.com/office/powerpoint/2010/main" val="3263309737"/>
       </p:ext>
     </p:extLst>
   </p:cSld>
@@ -8269,7 +8269,7 @@
             </a:r>
             <a:r>
               <a:rPr lang="en-US" b="1"/>
-              <a:t>One huge outlier is added to a dataset. Which moves more, the mean or the median?</a:t>
+              <a:t>One value is far larger than all the rest. Which moves more, the mean or the median?</a:t>
             </a:r>
             <a:endParaRPr lang="en-US" b="1" dirty="0"/>
           </a:p>
@@ -8284,7 +8284,7 @@
         <p:spPr>
           <a:xfrm>
             <a:off x="1066800" y="1655688"/>
-            <a:ext cx="10058400" cy="558560"/>
+            <a:ext cx="10058400" cy="650240"/>
           </a:xfrm>
           <a:prstGeom prst="rect">
             <a:avLst/>
@@ -8306,7 +8306,7 @@
                   <a:srgbClr val="C00000"/>
                 </a:solidFill>
               </a:rPr>
-              <a:t>The mean is pulled toward it. The median barely moves – it only cares about position in the ordered list.</a:t>
+              <a:t>The mean, which gets pulled toward it. The median barely moves – it only cares about position in the ordered list.</a:t>
             </a:r>
             <a:endParaRPr lang="en-US" dirty="0">
               <a:solidFill>
@@ -8360,7 +8360,7 @@
             </a:r>
             <a:r>
               <a:rPr lang="en-US" b="1"/>
-              <a:t>Besides the sum over n, what were the other two ways we wrote the mean?</a:t>
+              <a:t>We wrote the mean three different ways last time. What were they?</a:t>
             </a:r>
             <a:endParaRPr lang="en-US" b="1" dirty="0"/>
           </a:p>
@@ -8375,7 +8375,7 @@
         <p:spPr>
           <a:xfrm>
             <a:off x="1066800" y="2965688"/>
-            <a:ext cx="10058400" cy="558560"/>
+            <a:ext cx="10058400" cy="589280"/>
           </a:xfrm>
           <a:prstGeom prst="rect">
             <a:avLst/>
@@ -8392,18 +8392,13 @@
               <a:buNone/>
             </a:pPr>
             <a:r>
-              <a:rPr lang="en-US" sz="1600">
+              <a:rPr lang="en-US" sz="1600" dirty="0">
                 <a:solidFill>
                   <a:srgbClr val="C00000"/>
                 </a:solidFill>
               </a:rPr>
-              <a:t>From a frequency table, and from a relative frequency table. All three give the same number.</a:t>
-            </a:r>
-            <a:endParaRPr lang="en-US" sz="1600" dirty="0">
-              <a:solidFill>
-                <a:srgbClr val="C00000"/>
-              </a:solidFill>
-            </a:endParaRPr>
+              <a:t>Add the values and divide by n; or work from a frequency table; or from a relative frequency table. All three give the same number.</a:t>
+            </a:r>
           </a:p>
         </p:txBody>
       </p:sp>
@@ -8451,7 +8446,7 @@
             </a:r>
             <a:r>
               <a:rPr lang="en-US" b="1"/>
-              <a:t>What does it mean to say a score sits at the 75th percentile?</a:t>
+              <a:t>A student's exam score is at the 75th percentile. What does that tell you?</a:t>
             </a:r>
             <a:endParaRPr lang="en-US" b="1" dirty="0"/>
           </a:p>
@@ -8483,109 +8478,13 @@
               <a:buNone/>
             </a:pPr>
             <a:r>
-              <a:rPr lang="en-US" sz="1600">
+              <a:rPr lang="en-US" sz="1600" dirty="0">
                 <a:solidFill>
                   <a:srgbClr val="C00000"/>
                 </a:solidFill>
               </a:rPr>
-              <a:t>75 percent of the observations fall at or below that score.</a:t>
-            </a:r>
-            <a:endParaRPr lang="en-US" sz="1600" dirty="0">
-              <a:solidFill>
-                <a:srgbClr val="C00000"/>
-              </a:solidFill>
-            </a:endParaRPr>
-          </a:p>
-        </p:txBody>
-      </p:sp>
-      <p:sp>
-        <p:nvSpPr>
-          <p:cNvPr id="9" name="Question 4"/>
-          <p:cNvSpPr/>
-          <p:nvPr/>
-        </p:nvSpPr>
-        <p:spPr>
-          <a:xfrm>
-            <a:off x="838200" y="5005688"/>
-            <a:ext cx="10515600" cy="1230000"/>
-          </a:xfrm>
-          <a:prstGeom prst="roundRect">
-            <a:avLst>
-              <a:gd name="adj" fmla="val 4000"/>
-            </a:avLst>
-          </a:prstGeom>
-          <a:solidFill>
-            <a:srgbClr val="F2F6FC"/>
-          </a:solidFill>
-          <a:ln w="19050">
-            <a:solidFill>
-              <a:schemeClr val="accent1"/>
-            </a:solidFill>
-          </a:ln>
-        </p:spPr>
-        <p:txBody>
-          <a:bodyPr lIns="228600" tIns="182880" rIns="228600" bIns="91440" anchor="t">
-            <a:noAutofit/>
-          </a:bodyPr>
-          <a:lstStyle/>
-          <a:p>
-            <a:pPr marL="0" indent="0">
-              <a:buNone/>
-            </a:pPr>
-            <a:r>
-              <a:rPr lang="en-US" b="1">
-                <a:solidFill>
-                  <a:srgbClr val="C00000"/>
-                </a:solidFill>
-              </a:rPr>
-              <a:t>4   </a:t>
-            </a:r>
-            <a:r>
-              <a:rPr lang="en-US" b="1"/>
-              <a:t>You already have the median. How do you get Q1 and Q3 from it?</a:t>
-            </a:r>
-            <a:endParaRPr lang="en-US" b="1" dirty="0"/>
-          </a:p>
-        </p:txBody>
-      </p:sp>
-      <p:sp>
-        <p:nvSpPr>
-          <p:cNvPr id="10" name="Answer 4"/>
-          <p:cNvSpPr txBox="1"/>
-          <p:nvPr/>
-        </p:nvSpPr>
-        <p:spPr>
-          <a:xfrm>
-            <a:off x="1066800" y="5585688"/>
-            <a:ext cx="10058400" cy="589280"/>
-          </a:xfrm>
-          <a:prstGeom prst="rect">
-            <a:avLst/>
-          </a:prstGeom>
-          <a:noFill/>
-        </p:spPr>
-        <p:txBody>
-          <a:bodyPr wrap="square" lIns="0" tIns="0" rIns="0" bIns="0">
-            <a:noAutofit/>
-          </a:bodyPr>
-          <a:lstStyle/>
-          <a:p>
-            <a:pPr marL="0" indent="0">
-              <a:buNone/>
-            </a:pPr>
-            <a:r>
-              <a:rPr lang="en-US" sz="1600">
-                <a:solidFill>
-                  <a:srgbClr val="C00000"/>
-                </a:solidFill>
-              </a:rPr>
-              <a:t>Q1 is the median of the lower half, Q3 the median of the upper half – leaving the median itself out of both halves when n is odd.</a:t>
-            </a:r>
-            <a:endParaRPr lang="en-US" sz="1600" dirty="0">
-              <a:solidFill>
-                <a:srgbClr val="C00000"/>
-              </a:solidFill>
-            </a:endParaRPr>
+              <a:t>That 75 percent of the scores are at or below theirs.</a:t>
+            </a:r>
           </a:p>
         </p:txBody>
       </p:sp>
@@ -8906,96 +8805,6 @@
                       </p:childTnLst>
                     </p:cTn>
                   </p:par>
-                  <p:par>
-                    <p:cTn id="27" fill="hold">
-                      <p:stCondLst>
-                        <p:cond delay="indefinite"/>
-                      </p:stCondLst>
-                      <p:childTnLst>
-                        <p:par>
-                          <p:cTn id="28" fill="hold">
-                            <p:stCondLst>
-                              <p:cond delay="0"/>
-                            </p:stCondLst>
-                            <p:childTnLst>
-                              <p:par>
-                                <p:cTn id="29" presetID="1" presetClass="entr" presetSubtype="0" fill="hold" nodeType="clickEffect">
-                                  <p:stCondLst>
-                                    <p:cond delay="0"/>
-                                  </p:stCondLst>
-                                  <p:childTnLst>
-                                    <p:set>
-                                      <p:cBhvr>
-                                        <p:cTn id="30" dur="1" fill="hold">
-                                          <p:stCondLst>
-                                            <p:cond delay="0"/>
-                                          </p:stCondLst>
-                                        </p:cTn>
-                                        <p:tgtEl>
-                                          <p:spTgt spid="9"/>
-                                        </p:tgtEl>
-                                        <p:attrNameLst>
-                                          <p:attrName>style.visibility</p:attrName>
-                                        </p:attrNameLst>
-                                      </p:cBhvr>
-                                      <p:to>
-                                        <p:strVal val="visible"/>
-                                      </p:to>
-                                    </p:set>
-                                  </p:childTnLst>
-                                </p:cTn>
-                              </p:par>
-                            </p:childTnLst>
-                          </p:cTn>
-                        </p:par>
-                      </p:childTnLst>
-                    </p:cTn>
-                  </p:par>
-                  <p:par>
-                    <p:cTn id="31" fill="hold">
-                      <p:stCondLst>
-                        <p:cond delay="indefinite"/>
-                      </p:stCondLst>
-                      <p:childTnLst>
-                        <p:par>
-                          <p:cTn id="32" fill="hold">
-                            <p:stCondLst>
-                              <p:cond delay="0"/>
-                            </p:stCondLst>
-                            <p:childTnLst>
-                              <p:par>
-                                <p:cTn id="33" presetID="1" presetClass="entr" presetSubtype="0" fill="hold" nodeType="clickEffect">
-                                  <p:stCondLst>
-                                    <p:cond delay="0"/>
-                                  </p:stCondLst>
-                                  <p:childTnLst>
-                                    <p:set>
-                                      <p:cBhvr>
-                                        <p:cTn id="34" dur="1" fill="hold">
-                                          <p:stCondLst>
-                                            <p:cond delay="0"/>
-                                          </p:stCondLst>
-                                        </p:cTn>
-                                        <p:tgtEl>
-                                          <p:spTgt spid="10"/>
-                                        </p:tgtEl>
-                                        <p:attrNameLst>
-                                          <p:attrName>style.visibility</p:attrName>
-                                        </p:attrNameLst>
-                                      </p:cBhvr>
-                                      <p:to>
-                                        <p:strVal val="visible"/>
-                                      </p:to>
-                                    </p:set>
-                                  </p:childTnLst>
-                                </p:cTn>
-                              </p:par>
-                            </p:childTnLst>
-                          </p:cTn>
-                        </p:par>
-                      </p:childTnLst>
-                    </p:cTn>
-                  </p:par>
                 </p:childTnLst>
               </p:cTn>
               <p:prevCondLst>
@@ -9187,7 +8996,7 @@
           <p:cNvPr id="7" name="Picture 6">
             <a:extLst>
               <a:ext uri="{FF2B5EF4-FFF2-40B4-BE49-F238E27FC236}">
-                <a16:creationId xmlns:a16="http://schemas.microsoft.com/office/drawing/2014/main" id="{3C06871C-6A7C-FF82-79D1-6EA74E2EBEEE}"/>
+                <a16:creationId xmlns:a16="http://schemas.microsoft.com/office/drawing/2014/main" id="{95B7B0AA-BA0E-8CA3-43DA-81440F75A94A}"/>
               </a:ext>
             </a:extLst>
           </p:cNvPr>
@@ -9253,7 +9062,7 @@
           <p:cNvPr id="6" name="Body card">
             <a:extLst>
               <a:ext uri="{FF2B5EF4-FFF2-40B4-BE49-F238E27FC236}">
-                <a16:creationId xmlns:a16="http://schemas.microsoft.com/office/drawing/2014/main" id="{D4974225-2C16-6129-EC36-4FF36DBAA110}"/>
+                <a16:creationId xmlns:a16="http://schemas.microsoft.com/office/drawing/2014/main" id="{85B7623B-8C02-CE9B-1FBA-55C6D4A4870F}"/>
               </a:ext>
             </a:extLst>
           </p:cNvPr>
@@ -9309,7 +9118,7 @@
           <p:cNvPr id="2" name="Title 1">
             <a:extLst>
               <a:ext uri="{FF2B5EF4-FFF2-40B4-BE49-F238E27FC236}">
-                <a16:creationId xmlns:a16="http://schemas.microsoft.com/office/drawing/2014/main" id="{07620540-C008-B7C7-A878-4883070136A3}"/>
+                <a16:creationId xmlns:a16="http://schemas.microsoft.com/office/drawing/2014/main" id="{E2DBB32B-8553-F0C8-C769-AA9CA8B8A476}"/>
               </a:ext>
             </a:extLst>
           </p:cNvPr>
@@ -9343,7 +9152,7 @@
           <p:cNvPr id="3" name="Content Placeholder 2">
             <a:extLst>
               <a:ext uri="{FF2B5EF4-FFF2-40B4-BE49-F238E27FC236}">
-                <a16:creationId xmlns:a16="http://schemas.microsoft.com/office/drawing/2014/main" id="{25157FAC-5E3E-B77A-BFF0-3642EC930022}"/>
+                <a16:creationId xmlns:a16="http://schemas.microsoft.com/office/drawing/2014/main" id="{D427EA79-87D9-D3FD-EC21-58058CB1286C}"/>
               </a:ext>
             </a:extLst>
           </p:cNvPr>
@@ -9453,7 +9262,7 @@
           <p:cNvPr id="4" name="Slide Number Placeholder 3">
             <a:extLst>
               <a:ext uri="{FF2B5EF4-FFF2-40B4-BE49-F238E27FC236}">
-                <a16:creationId xmlns:a16="http://schemas.microsoft.com/office/drawing/2014/main" id="{2B0FD3F8-B60D-21BF-2F80-611A3F85C875}"/>
+                <a16:creationId xmlns:a16="http://schemas.microsoft.com/office/drawing/2014/main" id="{A969D8E8-25ED-D137-B516-42B577C8E3FA}"/>
               </a:ext>
             </a:extLst>
           </p:cNvPr>
@@ -9482,7 +9291,7 @@
           <p:cNvPr id="5" name="Title rule">
             <a:extLst>
               <a:ext uri="{FF2B5EF4-FFF2-40B4-BE49-F238E27FC236}">
-                <a16:creationId xmlns:a16="http://schemas.microsoft.com/office/drawing/2014/main" id="{BE10AAD4-EC77-292E-B471-6128AF2F68F1}"/>
+                <a16:creationId xmlns:a16="http://schemas.microsoft.com/office/drawing/2014/main" id="{EEFD88EB-AD79-5435-AD3C-AD4CF8F84C8A}"/>
               </a:ext>
             </a:extLst>
           </p:cNvPr>
@@ -9548,7 +9357,7 @@
     </p:spTree>
     <p:extLst>
       <p:ext uri="{BB962C8B-B14F-4D97-AF65-F5344CB8AC3E}">
-        <p14:creationId xmlns:p14="http://schemas.microsoft.com/office/powerpoint/2010/main" val="3951407327"/>
+        <p14:creationId xmlns:p14="http://schemas.microsoft.com/office/powerpoint/2010/main" val="547854258"/>
       </p:ext>
     </p:extLst>
   </p:cSld>
@@ -9575,8 +9384,8 @@
           <a:chExt cx="0" cy="0"/>
         </a:xfrm>
       </p:grpSpPr>
-      <mc:AlternateContent xmlns:mc="http://schemas.openxmlformats.org/markup-compatibility/2006">
-        <mc:Choice xmlns:a14="http://schemas.microsoft.com/office/drawing/2010/main" Requires="a14">
+      <mc:AlternateContent xmlns:mc="http://schemas.openxmlformats.org/markup-compatibility/2006" xmlns:a14="http://schemas.microsoft.com/office/drawing/2010/main">
+        <mc:Choice Requires="a14">
           <p:sp>
             <p:nvSpPr>
               <p:cNvPr id="4" name="Content Placeholder 2">
@@ -10625,7 +10434,7 @@
             </p:txBody>
           </p:sp>
         </mc:Choice>
-        <mc:Fallback>
+        <mc:Fallback xmlns="">
           <p:sp>
             <p:nvSpPr>
               <p:cNvPr id="4" name="Content Placeholder 2">
@@ -11142,7 +10951,7 @@
           <p:cNvPr id="8" name="Picture 7">
             <a:extLst>
               <a:ext uri="{FF2B5EF4-FFF2-40B4-BE49-F238E27FC236}">
-                <a16:creationId xmlns:a16="http://schemas.microsoft.com/office/drawing/2014/main" id="{EDB44561-A4CE-7482-1E3D-65C070E9226F}"/>
+                <a16:creationId xmlns:a16="http://schemas.microsoft.com/office/drawing/2014/main" id="{D5C4F961-D201-AF58-9F6E-765C4644B347}"/>
               </a:ext>
             </a:extLst>
           </p:cNvPr>
@@ -11617,7 +11426,7 @@
           <p:cNvPr id="8" name="Picture 7">
             <a:extLst>
               <a:ext uri="{FF2B5EF4-FFF2-40B4-BE49-F238E27FC236}">
-                <a16:creationId xmlns:a16="http://schemas.microsoft.com/office/drawing/2014/main" id="{8B2ECD84-5B26-61B8-6473-79FD7C0B50D1}"/>
+                <a16:creationId xmlns:a16="http://schemas.microsoft.com/office/drawing/2014/main" id="{7CC1D2F0-9293-5D71-7FB1-CDC4E9B92297}"/>
               </a:ext>
             </a:extLst>
           </p:cNvPr>
@@ -11846,7 +11655,7 @@
           <p:cNvPr id="4" name="Picture 3">
             <a:extLst>
               <a:ext uri="{FF2B5EF4-FFF2-40B4-BE49-F238E27FC236}">
-                <a16:creationId xmlns:a16="http://schemas.microsoft.com/office/drawing/2014/main" id="{44604045-066A-0CD2-DEA2-1677E8361871}"/>
+                <a16:creationId xmlns:a16="http://schemas.microsoft.com/office/drawing/2014/main" id="{30F572F7-4028-3BAD-0D06-22FF50BEED86}"/>
               </a:ext>
             </a:extLst>
           </p:cNvPr>
@@ -11882,7 +11691,7 @@
           <p:cNvPr id="5" name="Caption">
             <a:extLst>
               <a:ext uri="{FF2B5EF4-FFF2-40B4-BE49-F238E27FC236}">
-                <a16:creationId xmlns:a16="http://schemas.microsoft.com/office/drawing/2014/main" id="{256C2B1F-9D4F-86C8-89D3-EC961C0880D3}"/>
+                <a16:creationId xmlns:a16="http://schemas.microsoft.com/office/drawing/2014/main" id="{9F6E5139-DE79-325A-F07D-99D930CDF34F}"/>
               </a:ext>
             </a:extLst>
           </p:cNvPr>
@@ -11948,7 +11757,7 @@
           <p:cNvPr id="2" name="Title 1">
             <a:extLst>
               <a:ext uri="{FF2B5EF4-FFF2-40B4-BE49-F238E27FC236}">
-                <a16:creationId xmlns:a16="http://schemas.microsoft.com/office/drawing/2014/main" id="{302FDB51-7140-0F78-C250-266B48064A70}"/>
+                <a16:creationId xmlns:a16="http://schemas.microsoft.com/office/drawing/2014/main" id="{240E1A2D-56A4-17F4-71E6-F0DA2823F86E}"/>
               </a:ext>
             </a:extLst>
           </p:cNvPr>
@@ -11982,7 +11791,7 @@
           <p:cNvPr id="3" name="Content Placeholder 2">
             <a:extLst>
               <a:ext uri="{FF2B5EF4-FFF2-40B4-BE49-F238E27FC236}">
-                <a16:creationId xmlns:a16="http://schemas.microsoft.com/office/drawing/2014/main" id="{97A1A062-2FF0-861A-FC4B-7DB649630B41}"/>
+                <a16:creationId xmlns:a16="http://schemas.microsoft.com/office/drawing/2014/main" id="{1AB9645C-C773-7EB8-169A-3B4A6AA4C0C5}"/>
               </a:ext>
             </a:extLst>
           </p:cNvPr>
@@ -12035,7 +11844,7 @@
           <p:cNvPr id="4" name="Slide Number Placeholder 3">
             <a:extLst>
               <a:ext uri="{FF2B5EF4-FFF2-40B4-BE49-F238E27FC236}">
-                <a16:creationId xmlns:a16="http://schemas.microsoft.com/office/drawing/2014/main" id="{879B54D2-20FE-0D3B-E8CB-31469F126D30}"/>
+                <a16:creationId xmlns:a16="http://schemas.microsoft.com/office/drawing/2014/main" id="{613BC775-5437-BAF3-E0D2-166A2787EB25}"/>
               </a:ext>
             </a:extLst>
           </p:cNvPr>
@@ -12064,7 +11873,7 @@
           <p:cNvPr id="6" name="Picture 5">
             <a:extLst>
               <a:ext uri="{FF2B5EF4-FFF2-40B4-BE49-F238E27FC236}">
-                <a16:creationId xmlns:a16="http://schemas.microsoft.com/office/drawing/2014/main" id="{B0D487F7-EBA6-6E7E-D31D-88D99FC53423}"/>
+                <a16:creationId xmlns:a16="http://schemas.microsoft.com/office/drawing/2014/main" id="{203056D3-9047-86C3-059A-98A2F9ED5492}"/>
               </a:ext>
             </a:extLst>
           </p:cNvPr>
@@ -12100,7 +11909,7 @@
           <p:cNvPr id="5" name="Title rule">
             <a:extLst>
               <a:ext uri="{FF2B5EF4-FFF2-40B4-BE49-F238E27FC236}">
-                <a16:creationId xmlns:a16="http://schemas.microsoft.com/office/drawing/2014/main" id="{A48B0CF6-5AAA-9CD8-5755-0488329DE838}"/>
+                <a16:creationId xmlns:a16="http://schemas.microsoft.com/office/drawing/2014/main" id="{BDF2A375-024F-7A84-805F-E663A6FF4CA3}"/>
               </a:ext>
             </a:extLst>
           </p:cNvPr>
@@ -12166,7 +11975,7 @@
     </p:spTree>
     <p:extLst>
       <p:ext uri="{BB962C8B-B14F-4D97-AF65-F5344CB8AC3E}">
-        <p14:creationId xmlns:p14="http://schemas.microsoft.com/office/powerpoint/2010/main" val="1333014477"/>
+        <p14:creationId xmlns:p14="http://schemas.microsoft.com/office/powerpoint/2010/main" val="1720711337"/>
       </p:ext>
     </p:extLst>
   </p:cSld>
@@ -12198,7 +12007,7 @@
           <p:cNvPr id="2" name="Title 1">
             <a:extLst>
               <a:ext uri="{FF2B5EF4-FFF2-40B4-BE49-F238E27FC236}">
-                <a16:creationId xmlns:a16="http://schemas.microsoft.com/office/drawing/2014/main" id="{31783753-F233-F38B-A562-9F3E1735DE7B}"/>
+                <a16:creationId xmlns:a16="http://schemas.microsoft.com/office/drawing/2014/main" id="{FE89D985-6907-3BF5-2144-F2E2C71F5526}"/>
               </a:ext>
             </a:extLst>
           </p:cNvPr>
@@ -12232,7 +12041,7 @@
           <p:cNvPr id="3" name="Content Placeholder 2">
             <a:extLst>
               <a:ext uri="{FF2B5EF4-FFF2-40B4-BE49-F238E27FC236}">
-                <a16:creationId xmlns:a16="http://schemas.microsoft.com/office/drawing/2014/main" id="{F32C0194-7584-72D4-FE6D-3EA1A8839CF2}"/>
+                <a16:creationId xmlns:a16="http://schemas.microsoft.com/office/drawing/2014/main" id="{5A40331F-A33D-A21F-582E-3D5CAC223063}"/>
               </a:ext>
             </a:extLst>
           </p:cNvPr>
@@ -12287,7 +12096,7 @@
           <p:cNvPr id="4" name="Slide Number Placeholder 3">
             <a:extLst>
               <a:ext uri="{FF2B5EF4-FFF2-40B4-BE49-F238E27FC236}">
-                <a16:creationId xmlns:a16="http://schemas.microsoft.com/office/drawing/2014/main" id="{4324E8D2-53C2-3539-812C-7142CD3D1F06}"/>
+                <a16:creationId xmlns:a16="http://schemas.microsoft.com/office/drawing/2014/main" id="{F4A7958C-98B2-9EEB-50BA-A8510F037150}"/>
               </a:ext>
             </a:extLst>
           </p:cNvPr>
@@ -12316,7 +12125,7 @@
           <p:cNvPr id="6" name="Picture 5">
             <a:extLst>
               <a:ext uri="{FF2B5EF4-FFF2-40B4-BE49-F238E27FC236}">
-                <a16:creationId xmlns:a16="http://schemas.microsoft.com/office/drawing/2014/main" id="{F12D3E5F-A8C7-3EC9-354C-91E85E95EE60}"/>
+                <a16:creationId xmlns:a16="http://schemas.microsoft.com/office/drawing/2014/main" id="{239752E4-87F6-1E09-31FC-C410DE4E1C0C}"/>
               </a:ext>
             </a:extLst>
           </p:cNvPr>
@@ -12352,7 +12161,7 @@
           <p:cNvPr id="5" name="Title rule">
             <a:extLst>
               <a:ext uri="{FF2B5EF4-FFF2-40B4-BE49-F238E27FC236}">
-                <a16:creationId xmlns:a16="http://schemas.microsoft.com/office/drawing/2014/main" id="{2087FECE-E48C-1252-635B-D46EEF2C11AF}"/>
+                <a16:creationId xmlns:a16="http://schemas.microsoft.com/office/drawing/2014/main" id="{65CA14CE-677B-A3FA-FD66-2C47C52DFDF1}"/>
               </a:ext>
             </a:extLst>
           </p:cNvPr>
@@ -12418,7 +12227,7 @@
     </p:spTree>
     <p:extLst>
       <p:ext uri="{BB962C8B-B14F-4D97-AF65-F5344CB8AC3E}">
-        <p14:creationId xmlns:p14="http://schemas.microsoft.com/office/powerpoint/2010/main" val="2484407411"/>
+        <p14:creationId xmlns:p14="http://schemas.microsoft.com/office/powerpoint/2010/main" val="347221508"/>
       </p:ext>
     </p:extLst>
   </p:cSld>
@@ -12450,7 +12259,7 @@
           <p:cNvPr id="6" name="Body card">
             <a:extLst>
               <a:ext uri="{FF2B5EF4-FFF2-40B4-BE49-F238E27FC236}">
-                <a16:creationId xmlns:a16="http://schemas.microsoft.com/office/drawing/2014/main" id="{8E5DE3FF-1F72-B1BF-B50A-4EE6DBF3DF0A}"/>
+                <a16:creationId xmlns:a16="http://schemas.microsoft.com/office/drawing/2014/main" id="{A3BB14A2-A17B-0DDB-EE44-E49DC3E47367}"/>
               </a:ext>
             </a:extLst>
           </p:cNvPr>
@@ -12506,7 +12315,7 @@
           <p:cNvPr id="2" name="Title 1">
             <a:extLst>
               <a:ext uri="{FF2B5EF4-FFF2-40B4-BE49-F238E27FC236}">
-                <a16:creationId xmlns:a16="http://schemas.microsoft.com/office/drawing/2014/main" id="{0AA44164-6B58-06CE-3191-0E56300B4A2A}"/>
+                <a16:creationId xmlns:a16="http://schemas.microsoft.com/office/drawing/2014/main" id="{5ADB5192-65CD-99C0-DC8F-0AA402C5C88C}"/>
               </a:ext>
             </a:extLst>
           </p:cNvPr>
@@ -12540,7 +12349,7 @@
           <p:cNvPr id="3" name="Content Placeholder 2">
             <a:extLst>
               <a:ext uri="{FF2B5EF4-FFF2-40B4-BE49-F238E27FC236}">
-                <a16:creationId xmlns:a16="http://schemas.microsoft.com/office/drawing/2014/main" id="{D584DF1E-607F-1213-E819-64E72074D77B}"/>
+                <a16:creationId xmlns:a16="http://schemas.microsoft.com/office/drawing/2014/main" id="{3DD1FDB8-9175-1475-794C-EA230FB5EDCA}"/>
               </a:ext>
             </a:extLst>
           </p:cNvPr>
@@ -12620,7 +12429,7 @@
           <p:cNvPr id="4" name="Slide Number Placeholder 3">
             <a:extLst>
               <a:ext uri="{FF2B5EF4-FFF2-40B4-BE49-F238E27FC236}">
-                <a16:creationId xmlns:a16="http://schemas.microsoft.com/office/drawing/2014/main" id="{DE45CED9-A977-8A69-23B1-A77666C1551E}"/>
+                <a16:creationId xmlns:a16="http://schemas.microsoft.com/office/drawing/2014/main" id="{D1542E42-FFAE-A2EC-4B0B-8F87B962F446}"/>
               </a:ext>
             </a:extLst>
           </p:cNvPr>
@@ -12649,7 +12458,7 @@
           <p:cNvPr id="5" name="Title rule">
             <a:extLst>
               <a:ext uri="{FF2B5EF4-FFF2-40B4-BE49-F238E27FC236}">
-                <a16:creationId xmlns:a16="http://schemas.microsoft.com/office/drawing/2014/main" id="{A2B7FDA4-E096-B923-0A3A-F0682028F1EC}"/>
+                <a16:creationId xmlns:a16="http://schemas.microsoft.com/office/drawing/2014/main" id="{CBE738CD-BC27-DA57-351F-0762B3156092}"/>
               </a:ext>
             </a:extLst>
           </p:cNvPr>
@@ -12715,7 +12524,7 @@
     </p:spTree>
     <p:extLst>
       <p:ext uri="{BB962C8B-B14F-4D97-AF65-F5344CB8AC3E}">
-        <p14:creationId xmlns:p14="http://schemas.microsoft.com/office/powerpoint/2010/main" val="2971353410"/>
+        <p14:creationId xmlns:p14="http://schemas.microsoft.com/office/powerpoint/2010/main" val="148665817"/>
       </p:ext>
     </p:extLst>
   </p:cSld>
@@ -13215,8 +13024,8 @@
           </a:p>
         </p:txBody>
       </p:sp>
-      <mc:AlternateContent xmlns:mc="http://schemas.openxmlformats.org/markup-compatibility/2006">
-        <mc:Choice xmlns:a14="http://schemas.microsoft.com/office/drawing/2010/main" Requires="a14">
+      <mc:AlternateContent xmlns:mc="http://schemas.openxmlformats.org/markup-compatibility/2006" xmlns:a14="http://schemas.microsoft.com/office/drawing/2010/main">
+        <mc:Choice Requires="a14">
           <p:sp>
             <p:nvSpPr>
               <p:cNvPr id="3" name="Content Placeholder 2">
@@ -13408,7 +13217,7 @@
             </p:txBody>
           </p:sp>
         </mc:Choice>
-        <mc:Fallback>
+        <mc:Fallback xmlns="">
           <p:sp>
             <p:nvSpPr>
               <p:cNvPr id="3" name="Content Placeholder 2">
@@ -13816,7 +13625,7 @@
           <p:cNvPr id="7" name="Rectangle: Rounded Corners 6">
             <a:extLst>
               <a:ext uri="{FF2B5EF4-FFF2-40B4-BE49-F238E27FC236}">
-                <a16:creationId xmlns:a16="http://schemas.microsoft.com/office/drawing/2014/main" id="{B7896888-A574-06E0-6639-7FD1FB014F81}"/>
+                <a16:creationId xmlns:a16="http://schemas.microsoft.com/office/drawing/2014/main" id="{B4E34695-3BDE-3B38-CDD1-335B55EA7BAE}"/>
               </a:ext>
             </a:extLst>
           </p:cNvPr>

</xml_diff>